<commit_message>
test(asteroides): add integration tests for INT-AST-13/14/15 and update slides with real results
- Assets/Tests/IntegrationHypothesesTests.cs: 4 PlayMode tests. Three fail on
  purpose because they document real defects (batchmode, Unity 6000.3.11f1):
  - INT-AST-13: two lasers hitting one asteroid in the same physics step raise
    InvalidOperationException (double pool Release, Laser.cs:52); score ends at 2
  - INT-AST-14: NewGame does not remove asteroids from the previous game
    (ClearAsteroids disposes a pool that never holds on-screen asteroids)
  - INT-AST-15: calling NewGame twice spawns 8 asteroids in 2.1 s vs 5 with one call
    (StartCoroutine on the same IEnumerator)
- docs/clase-integracion-2: slides updated with real test output, regenerated
  coverage (7/7 PASS, 73.6% lines of GameAssembly) and verified prefab data

Co-Authored-By: Claude Opus 5.5 <noreply@anthropic.com>
</commit_message>
<xml_diff>
--- a/docs/clase-integracion-2/Testing-Integracion-II.pptx
+++ b/docs/clase-integracion-2/Testing-Integracion-II.pptx
@@ -598,7 +598,7 @@
           <a:lstStyle/>
           <a:p>
             <a:r>
-              <a:t>5 min. Puntos de discusión: (1) el flujo B ya tiene positivos (02 y 04): aceptar que un grupo proponga 'GameOver muestra el texto de Game Over' (gameOverText, Game.cs 64) como positivo válido; (2) INT-AST-08 reemplaza con ventaja a 03, que simula el Game Over poniendo isGameOver = true a mano: un estado que el juego nunca produce así; (3) INT-AST-10 necesita un objeto de prueba (un cubo con collider) que no existe en el juego: primer ejemplo de dato de prueba artificial. [A VERIFICAR] que el prefab del láser tenga Rigidbody; si no, el cubo necesita uno para que ocurra OnCollisionEnter.</a:t>
+              <a:t>5 min. Puntos de discusión: (1) el flujo B ya tiene positivos (02 y 04): aceptar que un grupo proponga 'GameOver muestra el texto de Game Over' (gameOverText, Game.cs 64) como positivo válido; (2) INT-AST-08 reemplaza con ventaja a 03, que simula el Game Over poniendo isGameOver = true a mano: un estado que el juego nunca produce así; (3) INT-AST-10 necesita un objeto de prueba (un cubo con collider) que no existe en el juego: primer ejemplo de dato de prueba artificial. Verificado: el prefab Laser tiene Rigidbody dinámico y BoxCollider, así que un cubo con solo un collider alcanza para que ocurra OnCollisionEnter.</a:t>
             </a:r>
           </a:p>
         </p:txBody>
@@ -738,7 +738,7 @@
           <a:lstStyle/>
           <a:p>
             <a:r>
-              <a:t>5 min. Las filas ⚠ no se resuelven por inferencia: se registran como pregunta al diseño y el caso queda pendiente hasta tener respuesta. INT-AST-13 (hipótesis por lectura de código): ambos Laser.OnCollisionEnter corren antes de que Destroy se haga efectivo → Game.AsteroidDestroyed() se llama dos veces (score 2) y el segundo spawner.asteroids.Release(...) debería lanzar InvalidOperationException, porque el ObjectPool controla dobles liberaciones (collectionCheck). Un test de Unity falla ante una excepción no esperada en el log. Confirmarlo ejecutando antes de afirmarlo en clase.</a:t>
+              <a:t>5 min. Las filas ⚠ no se resuelven por inferencia: se registran como pregunta al diseño y el caso queda pendiente hasta tener respuesta. Resultados reales (Unity 6000.3.11f1, batchmode, 28/09/2026, Assets/Tests/IntegrationHypothesesTests.cs). INT-AST-13: FAIL con «Unhandled log message: InvalidOperationException: Trying to release an object that has already been released to the pool», lanzada en Laser.cs:52; en una corrida de diagnóstico que ignoraba ese error, el score quedó en 2. Causa: los dos OnCollisionEnter corren antes de que Destroy se haga efectivo. INT-AST-15: con una llamada a NewGame aparecen 5 asteroides en 2,1 s; con dos llamadas seguidas, 8 (nave alejada para evitar un Game Over que detendría el spawner). Causa: StartCoroutine sobre el mismo IEnumerator (Spawner.cs 49–62).</a:t>
             </a:r>
           </a:p>
         </p:txBody>
@@ -878,7 +878,7 @@
           <a:lstStyle/>
           <a:p>
             <a:r>
-              <a:t>Demo de 5 min comparando con TestSuite.cs 40–51. [UnitySetUp] y [UnityTearDown] son atributos del Unity Test Framework que permiten usar yield. FindObjectsByType por defecto ignora objetos inactivos: la plantilla inactiva del láser, si está dentro del prefab, no se toca. Sin evidencia de ejecución, el estado de esta fixture es UNKNOWN.</a:t>
+              <a:t>Demo de 5 min comparando con TestSuite.cs 40–51. [UnitySetUp] y [UnityTearDown] son atributos del Unity Test Framework que permiten usar yield. FindObjectsByType por defecto ignora objetos inactivos: la plantilla inactiva del láser, si está dentro del prefab, no se toca. Evidencia: una limpieza equivalente se usa en Assets/Tests/IntegrationHypothesesTests.cs y corrió en batchmode el 28/09/2026. La parte de Random.InitState no se ejecutó: su estado es UNKNOWN.</a:t>
             </a:r>
           </a:p>
         </p:txBody>
@@ -1088,7 +1088,7 @@
           <a:lstStyle/>
           <a:p>
             <a:r>
-              <a:t>IMPORTANTE: la salida mostrada es una PREDICCIÓN hecha leyendo el código, no una ejecución. Correr el test antes de la clase y reemplazar la salida por la real. Objetivo: practicar el análisis de causa raíz de un fallo de integración. Resultado esperado: una cadena causal con archivo y líneas, más un ticket. Discusión: ¿cómo sabemos que el resultado esperado es correcto? (ver resolución).</a:t>
+              <a:t>La salida es REAL: Unity 6000.3.11f1 en batchmode, 28/09/2026, test en Assets/Tests/IntegrationHypothesesTests.cs. La primera línea (yield return null) es necesaria: sin ella, Game.GameOver() se ejecuta antes de que Start() asigne Game.instance. Objetivo: practicar el análisis de causa raíz de un fallo de integración. Resultado esperado: una cadena causal con archivo y líneas, más un ticket. Discusión: ¿cómo sabemos que el resultado esperado es correcto? (ver resolución).</a:t>
             </a:r>
           </a:p>
         </p:txBody>
@@ -1158,7 +1158,7 @@
           <a:lstStyle/>
           <a:p>
             <a:r>
-              <a:t>5 min. (1) ¿Juego o test? El test está bien construido: el asteroide está lejos de la nave, el spawner automático recién crea uno nuevo a los 0,4 s y se espera 1 frame. El nombre ClearAsteroids sugiere la intención, pero NO inferir el requisito: confirmarlo con diseño. Si el diseño dijera que los asteroides deben seguir cayendo, el que está mal es el test. (2) Causa: el pool se construye con SpawnAsteroid como función de creación (Spawner.cs 52–53) pero nunca se llama a Get(); SpawnAsteroid se usa directo. Laser.cs 52 hace Release de objetos que nunca se pidieron al pool. (3) Impacto: con un reinicio rápido, un asteroide viejo puede chocar la nave en (0,0,0) → Game Over inmediato. (4) Ticket con pasos, esperado/actual y evidencia (salida del test). (5) Regresión: el test queda en rojo hasta el arreglo y luego protege contra la reaparición del defecto.</a:t>
+              <a:t>5 min. Confirmado ejecutando (FAIL, Expected True / But was False). (1) ¿Juego o test? El test está bien construido: el asteroide está lejos de la nave, el spawner automático recién crea uno nuevo a los 0,4 s y se espera 1 frame. El nombre ClearAsteroids sugiere la intención, pero NO inferir el requisito: confirmarlo con diseño. Si el diseño dijera que los asteroides deben seguir cayendo, el que está mal es el test. (2) Causa: el pool se construye con SpawnAsteroid como función de creación (Spawner.cs 52–53) pero nunca se llama a Get(); SpawnAsteroid se usa directo. Laser.cs 52 hace Release de objetos que nunca se pidieron al pool. (3) Impacto: con un reinicio rápido, un asteroide viejo puede chocar la nave en (0,0,0) → Game Over inmediato. (4) Ticket con pasos, esperado/actual y evidencia (salida del test). (5) Regresión: el test queda en rojo hasta el arreglo y luego protege contra la reaparición del defecto.</a:t>
             </a:r>
           </a:p>
         </p:txBody>
@@ -1368,7 +1368,7 @@
           <a:lstStyle/>
           <a:p>
             <a:r>
-              <a:t>2 min de demo del problema + discusión. Conecta con la clase de plataformas: la misma separación de la entrada que permite portar a móvil permite testear la regla. No instalar el paquete Input System sin autorización. En el reporte de cobertura, Ship.cs 61–74 figura como no ejecutado.</a:t>
+              <a:t>2 min de demo del problema + discusión. Conecta con la clase de plataformas: la misma separación de la entrada que permite portar a móvil permite testear la regla. Verificado en Packages/manifest.json: el proyecto NO tiene el paquete Input System. No instalarlo sin autorización. En el reporte regenerado, Ship.cs 61–74 no se ejecuta: durante los frames de los tests la nave está «muerta» (isDead empieza en true y solo RepairShip lo cambia), así que Update sale en la línea 57.</a:t>
             </a:r>
           </a:p>
         </p:txBody>
@@ -1438,7 +1438,7 @@
           <a:lstStyle/>
           <a:p>
             <a:r>
-              <a:t>5 min + 3 de demo abriendo el reporte. Datos verificados leyendo los archivos: Summary.md indica 'MultiReportParser (6x OpenCoverParser)', 18 archivos para 6 clases y 644 líneas coverables sobre 616 totales (inconsistente: el resumen suma corridas). Tests_TestSuite.html muestra ejecutadas solo las líneas de GameOverStopsSpawningAndDisablesShip. Recomendación: regenerar el reporte con la suite completa en una carpeta limpia antes de la clase. Paquete: Code Coverage de Unity (docs.unity3d.com/Packages/com.unity.testtools.codecoverage@1.2).</a:t>
+              <a:t>5 min + 3 de demo abriendo el reporte. Reporte VIEJO (Asteroides/asteroide-final/CodeCoverage): 'MultiReportParser (6x OpenCoverParser)', 3 carpetas de resultados (cada corrida genera 2 XML), incluye el assembly de tests y reporta 644 líneas coverables sobre 616 totales; su vista línea por línea corresponde a una corrida con un solo test. Reporte REGENERADO (Unity 6000.3.11f1, batchmode, 28/09/2026, -testFilter TestSuite, assemblyFilters:+GameAssembly, carpeta limpia fuera del repo): 7/7 PASS; 137 de 186 líneas (73,6 %); 27 de 31 métodos (87 %); Asteroid 84,2 %, Game 100 %, Laser 81,2 %, Ship 43 %, Spawner 86,9 %. Sin cubrir: Ship 61–74 (la nave está muerta durante los frames de los tests), Ship 99–115 (MoveLeft/MoveRight), Asteroid 48 (destrucción bajo y = −5), Spawner 69 (spawn automático), Laser 42 (láser fuera de pantalla). Game.cs 85 figura cubierta (2 visitas, tests 06 y 07) aunque ningún assert la verifica. Paquete: Code Coverage 1.3 (docs.unity3d.com/Packages/com.unity.testtools.codecoverage@1.3).</a:t>
             </a:r>
           </a:p>
         </p:txBody>
@@ -1648,7 +1648,7 @@
           <a:lstStyle/>
           <a:p>
             <a:r>
-              <a:t>5 min. Suite final: 11 tests. Justificaciones: 03 simula un Game Over que el juego no produce y 08 lo cubre con el flujo real; 07 queda absorbido por 09, que verifica el puntaje y el texto (contra: si falla 09 hay que mirar el mensaje del Assert para saber cuál de los dos falló); 01 y 05 verifican el movimiento de un componente: pueden ir a una carpeta de tests por componente. 13 y 15 son hipótesis: si al ejecutarlos pasan, igual quedan como protección. Criterio de independencia: cada test debe poder correr solo y en cualquier orden.</a:t>
+              <a:t>5 min. Suite final: 11 tests. Justificaciones: 03 simula un Game Over que el juego no produce y 08 lo cubre con el flujo real; 07 queda absorbido por 09, que verifica el puntaje y el texto (contra: si falla 09 hay que mirar el mensaje del Assert para saber cuál de los dos falló); 01 y 05 verifican el movimiento de un componente: pueden ir a una carpeta de tests por componente. 13, 14 y 15 ya se ejecutaron y FALLAN: quedan en rojo como tests de regresión hasta que se corrijan los defectos. Criterio de independencia: cada test debe poder correr solo y en cualquier orden.</a:t>
             </a:r>
           </a:p>
         </p:txBody>
@@ -1788,7 +1788,7 @@
           <a:lstStyle/>
           <a:p>
             <a:r>
-              <a:t>Fichas completas (8 campos) de cada caso en la guía entregada junto con esta presentación.</a:t>
+              <a:t>Resultados de 13–15: 13 → excepción en Laser.cs:52 y score 2; 14 → el asteroide previo sobrevive; 15 → 8 asteroides con doble NewGame contra 5 con uno.</a:t>
             </a:r>
           </a:p>
         </p:txBody>
@@ -1858,7 +1858,7 @@
           <a:lstStyle/>
           <a:p>
             <a:r>
-              <a:t>Referencias verificadas: Unity Test Framework (docs.unity3d.com/Packages/com.unity.test-framework@1.4), Input System Testing (docs.unity3d.com/Packages/com.unity.inputsystem@1.11/manual/Testing.html), LogAssert (docs.unity3d.com/Packages/com.unity.test-framework@1.4/api/UnityEngine.TestTools.LogAssert.html), ObjectPool (docs.unity3d.com/ScriptReference/Pool.ObjectPool_1.html).</a:t>
+              <a:t>Referencias verificadas (versiones del proyecto: Test Framework 1.6.0, Code Coverage 1.3.0): Unity Test Framework (docs.unity3d.com/Packages/com.unity.test-framework@1.6), Input System Testing (docs.unity3d.com/Packages/com.unity.inputsystem@1.11/manual/Testing.html), LogAssert (docs.unity3d.com/Packages/com.unity.test-framework@1.4/api/UnityEngine.TestTools.LogAssert.html), ObjectPool (docs.unity3d.com/ScriptReference/Pool.ObjectPool_1.html).</a:t>
             </a:r>
           </a:p>
         </p:txBody>
@@ -2068,7 +2068,7 @@
           <a:lstStyle/>
           <a:p>
             <a:r>
-              <a:t>5 min. Las cuatro preguntas son el mapa de la clase: 1 → Actividad 3 (INT-AST-14); 2 → Actividad 2 (INT-AST-13); 3 → Actividad 1 (INT-AST-11); 4 → Bloque 4 (cobertura). Mostrar la imagen de Summary.md del reporte real (CodeCoverage/Report).</a:t>
+              <a:t>5 min. Las cuatro preguntas son el mapa de la clase: 1 → Actividad 3 (INT-AST-14); 2 → Actividad 2 (INT-AST-13); 3 → Actividad 1 (INT-AST-11); 4 → Bloque 4 (cobertura). Datos reales: la suite de 7 tests se ejecutó en batchmode el 28/09/2026 (7/7 PASS) con cobertura en una carpeta limpia.</a:t>
             </a:r>
           </a:p>
         </p:txBody>
@@ -2278,7 +2278,7 @@
           <a:lstStyle/>
           <a:p>
             <a:r>
-              <a:t>Este es el formato de ficha que usarán en las actividades (8 campos). En el juego real los asteroides aparecen en x aleatoria entre −8 y 8 (Spawner.cs 101–107), así que el choque entre asteroides es posible. [A VERIFICAR] que los prefabs de asteroides tengan Rigidbody y collider no-trigger: el proyecto no incluye la carpeta Assets/ en el repositorio.</a:t>
+              <a:t>Este es el formato de ficha que usarán en las actividades (8 campos). En el juego real los asteroides aparecen en x aleatoria entre −8 y 8 (Spawner.cs 101–107), así que el choque entre asteroides es posible. Verificado en los prefabs (rama activity-r-player-health): Asteroid, Asteroid2, Asteroid3 y Asteroid4 tienen Rigidbody dinámico sin gravedad y BoxCollider que no es trigger, así que el choque entre asteroides genera OnCollisionEnter.</a:t>
             </a:r>
           </a:p>
         </p:txBody>
@@ -6603,7 +6603,7 @@
                 </a:solidFill>
                 <a:latin typeface="Calibri"/>
               </a:rPr>
-              <a:t>ℹ  HUD: scoreText es privado → hay que ubicarlo por nombre en el prefab o exponer un getter (PROPUESTA).</a:t>
+              <a:t>ℹ  HUD: scoreText es privado, pero está dentro del prefab Game (UICanvas/ScoreText): el test puede encontrarlo con GetComponentsInChildren&lt;Text&gt;().</a:t>
             </a:r>
           </a:p>
         </p:txBody>
@@ -8034,7 +8034,7 @@
                           </a:solidFill>
                           <a:latin typeface="Calibri"/>
                         </a:rPr>
-                        <a:t>score +1 y sin excepción → INT-AST-13 (HIPÓTESIS: hoy suma 2)</a:t>
+                        <a:t>score +1 y sin excepción → INT-AST-13 (EJECUTADO: suma 2 y lanza excepción)</a:t>
                       </a:r>
                     </a:p>
                   </a:txBody>
@@ -8204,7 +8204,7 @@
                           </a:solidFill>
                           <a:latin typeface="Calibri"/>
                         </a:rPr>
-                        <a:t>Una sola corrutina de spawn → INT-AST-15 (HIPÓTESIS)</a:t>
+                        <a:t>Misma tasa de aparición → INT-AST-15 (EJECUTADO: 8 asteroides vs. 5)</a:t>
                       </a:r>
                     </a:p>
                   </a:txBody>
@@ -9833,7 +9833,7 @@
                 </a:solidFill>
                 <a:latin typeface="Calibri"/>
               </a:rPr>
-              <a:t>ℹ  Código propio de la cátedra (PROPUESTA), no incluido en el proyecto. No se probó todavía en Unity.</a:t>
+              <a:t>ℹ  Código propio de la cátedra. La limpieza (UnityTearDown) ya corre en IntegrationHypothesesTests.cs; la semilla no se probó.</a:t>
             </a:r>
           </a:p>
         </p:txBody>
@@ -11797,18 +11797,18 @@
           <a:lstStyle/>
           <a:p>
             <a:r>
-              <a:rPr sz="1200" b="0" i="0">
+              <a:rPr sz="1150" b="0" i="0">
                 <a:solidFill>
                   <a:srgbClr val="E2E8F0"/>
                 </a:solidFill>
                 <a:latin typeface="Consolas"/>
               </a:rPr>
-              <a:t>[UnityTest]  // INT-AST-14 (PROPUESTA)</a:t>
-            </a:r>
-          </a:p>
-          <a:p>
-            <a:r>
-              <a:rPr sz="1200" b="0" i="0">
+              <a:t>[UnityTest]  // INT-AST-14 · IntegrationHypothesesTests.cs</a:t>
+            </a:r>
+          </a:p>
+          <a:p>
+            <a:r>
+              <a:rPr sz="1150" b="0" i="0">
                 <a:solidFill>
                   <a:srgbClr val="E2E8F0"/>
                 </a:solidFill>
@@ -11819,7 +11819,7 @@
           </a:p>
           <a:p>
             <a:r>
-              <a:rPr sz="1200" b="0" i="0">
+              <a:rPr sz="1150" b="0" i="0">
                 <a:solidFill>
                   <a:srgbClr val="E2E8F0"/>
                 </a:solidFill>
@@ -11830,18 +11830,29 @@
           </a:p>
           <a:p>
             <a:r>
-              <a:rPr sz="1200" b="0" i="0">
+              <a:rPr sz="1150" b="0" i="0">
                 <a:solidFill>
                   <a:srgbClr val="E2E8F0"/>
                 </a:solidFill>
                 <a:latin typeface="Consolas"/>
               </a:rPr>
+              <a:t>    yield return null;                     // Start() asigna Game.instance</a:t>
+            </a:r>
+          </a:p>
+          <a:p>
+            <a:r>
+              <a:rPr sz="1150" b="0" i="0">
+                <a:solidFill>
+                  <a:srgbClr val="E2E8F0"/>
+                </a:solidFill>
+                <a:latin typeface="Consolas"/>
+              </a:rPr>
               <a:t>    game.NewGame();</a:t>
             </a:r>
           </a:p>
           <a:p>
             <a:r>
-              <a:rPr sz="1200" b="0" i="0">
+              <a:rPr sz="1150" b="0" i="0">
                 <a:solidFill>
                   <a:srgbClr val="E2E8F0"/>
                 </a:solidFill>
@@ -11852,7 +11863,7 @@
           </a:p>
           <a:p>
             <a:r>
-              <a:rPr sz="1200" b="0" i="0">
+              <a:rPr sz="1150" b="0" i="0">
                 <a:solidFill>
                   <a:srgbClr val="E2E8F0"/>
                 </a:solidFill>
@@ -11863,7 +11874,7 @@
           </a:p>
           <a:p>
             <a:r>
-              <a:rPr sz="1200" b="0" i="0">
+              <a:rPr sz="1150" b="0" i="0">
                 <a:solidFill>
                   <a:srgbClr val="E2E8F0"/>
                 </a:solidFill>
@@ -11874,7 +11885,7 @@
           </a:p>
           <a:p>
             <a:r>
-              <a:rPr sz="1200" b="0" i="0">
+              <a:rPr sz="1150" b="0" i="0">
                 <a:solidFill>
                   <a:srgbClr val="E2E8F0"/>
                 </a:solidFill>
@@ -11885,7 +11896,7 @@
           </a:p>
           <a:p>
             <a:r>
-              <a:rPr sz="1200" b="0" i="0">
+              <a:rPr sz="1150" b="0" i="0">
                 <a:solidFill>
                   <a:srgbClr val="E2E8F0"/>
                 </a:solidFill>
@@ -11896,7 +11907,7 @@
           </a:p>
           <a:p>
             <a:r>
-              <a:rPr sz="1200" b="0" i="0">
+              <a:rPr sz="1150" b="0" i="0">
                 <a:solidFill>
                   <a:srgbClr val="E2E8F0"/>
                 </a:solidFill>
@@ -11907,7 +11918,7 @@
           </a:p>
           <a:p>
             <a:r>
-              <a:rPr sz="1200" b="0" i="0">
+              <a:rPr sz="1150" b="0" i="0">
                 <a:solidFill>
                   <a:srgbClr val="E2E8F0"/>
                 </a:solidFill>
@@ -11918,7 +11929,7 @@
           </a:p>
           <a:p>
             <a:r>
-              <a:rPr sz="1200" b="0" i="0">
+              <a:rPr sz="1150" b="0" i="0">
                 <a:solidFill>
                   <a:srgbClr val="E2E8F0"/>
                 </a:solidFill>
@@ -11929,7 +11940,7 @@
           </a:p>
           <a:p>
             <a:r>
-              <a:rPr sz="1200" b="0" i="0">
+              <a:rPr sz="1150" b="0" i="0">
                 <a:solidFill>
                   <a:srgbClr val="E2E8F0"/>
                 </a:solidFill>
@@ -11940,7 +11951,7 @@
           </a:p>
           <a:p>
             <a:r>
-              <a:rPr sz="1200" b="0" i="0">
+              <a:rPr sz="1150" b="0" i="0">
                 <a:solidFill>
                   <a:srgbClr val="E2E8F0"/>
                 </a:solidFill>
@@ -11951,7 +11962,7 @@
           </a:p>
           <a:p>
             <a:r>
-              <a:rPr sz="1200" b="0" i="0">
+              <a:rPr sz="1150" b="0" i="0">
                 <a:solidFill>
                   <a:srgbClr val="E2E8F0"/>
                 </a:solidFill>
@@ -11962,18 +11973,18 @@
           </a:p>
           <a:p>
             <a:r>
-              <a:rPr sz="1200" b="0" i="0">
+              <a:rPr sz="1150" b="0" i="0">
                 <a:solidFill>
                   <a:srgbClr val="FCA5A5"/>
                 </a:solidFill>
                 <a:latin typeface="Consolas"/>
               </a:rPr>
-              <a:t>✗ NewGame_RemovesLeftoverAsteroids — NewGame debería eliminar los asteroides previos</a:t>
-            </a:r>
-          </a:p>
-          <a:p>
-            <a:r>
-              <a:rPr sz="1200" b="0" i="0">
+              <a:t>✗ FAIL (batchmode 28/09/2026) — NewGame debería eliminar los asteroides previos</a:t>
+            </a:r>
+          </a:p>
+          <a:p>
+            <a:r>
+              <a:rPr sz="1150" b="0" i="0">
                 <a:solidFill>
                   <a:srgbClr val="FCA5A5"/>
                 </a:solidFill>
@@ -16191,7 +16202,7 @@
         <p:spPr>
           <a:xfrm>
             <a:off x="502920" y="1280160"/>
-            <a:ext cx="4951476" cy="310896"/>
+            <a:ext cx="5340096" cy="310896"/>
           </a:xfrm>
           <a:prstGeom prst="roundRect">
             <a:avLst>
@@ -16232,7 +16243,7 @@
                 </a:solidFill>
                 <a:latin typeface="Calibri"/>
               </a:rPr>
-              <a:t>Ejemplo: CodeCoverage/Report del proyecto nave + asteroides</a:t>
+              <a:t>Ejemplo: Reporte regenerado: 7 tests, carpeta limpia, 28/09/2026</a:t>
             </a:r>
           </a:p>
         </p:txBody>
@@ -16246,7 +16257,7 @@
         <p:spPr>
           <a:xfrm>
             <a:off x="502920" y="1755648"/>
-            <a:ext cx="7315200" cy="2362199"/>
+            <a:ext cx="7315200" cy="2600325"/>
           </a:xfrm>
           <a:prstGeom prst="rect">
             <a:avLst/>
@@ -16280,7 +16291,7 @@
                 </a:solidFill>
                 <a:latin typeface="Calibri"/>
               </a:rPr>
-              <a:t>El resumen dice 65,5 % de líneas… pero mezcla 6 archivos de corridas distintas (15/09 y 18/09)</a:t>
+              <a:t>Reporte viejo del repo: 65,5 %, mezclando 3 corridas (15/09 y 18/09) y el código de los tests</a:t>
             </a:r>
           </a:p>
           <a:p>
@@ -16305,7 +16316,7 @@
                 </a:solidFill>
                 <a:latin typeface="Calibri"/>
               </a:rPr>
-              <a:t>El detalle línea por línea viene de una corrida donde se ejecutó solo 1 de los 7 tests</a:t>
+              <a:t>Regenerado: 73,6 % de líneas y 87 % de métodos de GameAssembly · Game.cs 100 % · Ship.cs 43 %</a:t>
             </a:r>
           </a:p>
           <a:p>
@@ -16330,7 +16341,7 @@
                 </a:solidFill>
                 <a:latin typeface="Calibri"/>
               </a:rPr>
-              <a:t>Cobertura de ramas: 0 de 0 → no se midió</a:t>
+              <a:t>Game.cs 100 %… pero la línea del HUD (85) se ejecuta sin que ningún test la compruebe</a:t>
             </a:r>
           </a:p>
           <a:p>
@@ -16355,7 +16366,7 @@
                 </a:solidFill>
                 <a:latin typeface="Calibri"/>
               </a:rPr>
-              <a:t>Ship.Update (entrada del jugador) no aparece ejecutado en ningún test</a:t>
+              <a:t>Nunca ejecutado: entrada del jugador, movimiento lateral, asteroide que sale de pantalla, spawn automático</a:t>
             </a:r>
           </a:p>
           <a:p>
@@ -16380,7 +16391,7 @@
                 </a:solidFill>
                 <a:latin typeface="Calibri"/>
               </a:rPr>
-              <a:t>Cobertura = código EJECUTADO, no VERIFICADO: el test 07 recorre la línea del HUD sin comprobarla</a:t>
+              <a:t>Cobertura de ramas: 0 de 0 → no se midió</a:t>
             </a:r>
           </a:p>
         </p:txBody>
@@ -16467,7 +16478,7 @@
                 </a:solidFill>
                 <a:latin typeface="Calibri"/>
               </a:rPr>
-              <a:t>CodeCoverage/Report/Summary.md · Tests_TestSuite.html (solo 88–115 ejecutadas) · GameAssembly_Ship.html (61–74)</a:t>
+              <a:t>Sin cubrir: Ship.cs 61–74 y 99–115 · Asteroid.cs 48 · Spawner.cs 69 · Laser.cs 42 — Ejecutada sin verificar: Game.cs 85</a:t>
             </a:r>
           </a:p>
         </p:txBody>
@@ -16545,7 +16556,7 @@
                 </a:solidFill>
                 <a:latin typeface="Calibri"/>
               </a:rPr>
-              <a:t>❓  ¿Qué significa realmente el 65,5 %? ¿Lo usarían para decidir si el juego está listo?</a:t>
+              <a:t>❓  Game.cs tiene 100 % de cobertura: ¿está bien probado? ¿Usarían ese número para decidir si el juego está listo?</a:t>
             </a:r>
           </a:p>
         </p:txBody>
@@ -16617,7 +16628,7 @@
                 </a:solidFill>
                 <a:latin typeface="Calibri"/>
               </a:rPr>
-              <a:t>Captura de Summary.md del reporte (65,5 %, 6x OpenCoverParser, branches 0/0) junto a la vista línea por línea de Laser.cs en rojo.</a:t>
+              <a:t>Captura del reporte regenerado: resumen por clase (Game 100 %, Ship 43 %) y la vista línea por línea de Ship.cs con las líneas 61–74 en rojo.</a:t>
             </a:r>
           </a:p>
         </p:txBody>
@@ -20211,7 +20222,7 @@
                           </a:solidFill>
                           <a:latin typeface="Calibri"/>
                         </a:rPr>
-                        <a:t>HIPÓTESIS</a:t>
+                        <a:t>EJECUTADO · FAIL</a:t>
                       </a:r>
                     </a:p>
                   </a:txBody>
@@ -20301,7 +20312,7 @@
                           </a:solidFill>
                           <a:latin typeface="Calibri"/>
                         </a:rPr>
-                        <a:t>HIPÓTESIS de fallo</a:t>
+                        <a:t>EJECUTADO · FAIL</a:t>
                       </a:r>
                     </a:p>
                   </a:txBody>
@@ -20391,7 +20402,7 @@
                           </a:solidFill>
                           <a:latin typeface="Calibri"/>
                         </a:rPr>
-                        <a:t>HIPÓTESIS</a:t>
+                        <a:t>EJECUTADO · FAIL</a:t>
                       </a:r>
                     </a:p>
                   </a:txBody>
@@ -20569,7 +20580,7 @@
                 </a:solidFill>
                 <a:latin typeface="Calibri"/>
               </a:rPr>
-              <a:t>ℹ  PROPUESTA: no existe en el proyecto. HIPÓTESIS: resultado predicho leyendo el código, sin ejecutar.</a:t>
+              <a:t>ℹ  PROPUESTA: todavía no existe en el proyecto. EJECUTADO: en Assets/Tests/IntegrationHypothesesTests.cs (batchmode, 28/09/2026).</a:t>
             </a:r>
           </a:p>
         </p:txBody>
@@ -23998,7 +24009,7 @@
         <p:spPr>
           <a:xfrm>
             <a:off x="502920" y="1280160"/>
-            <a:ext cx="7315200" cy="1985010"/>
+            <a:ext cx="7315200" cy="2254885"/>
           </a:xfrm>
           <a:prstGeom prst="rect">
             <a:avLst/>
@@ -24107,7 +24118,7 @@
                 </a:solidFill>
                 <a:latin typeface="Calibri"/>
               </a:rPr>
-              <a:t>El reporte de cobertura dice 65,5 %. ¿Qué tan protegidos estamos?</a:t>
+              <a:t>El reporte de cobertura dice 73,6 %, y Game.cs tiene 100 %. ¿Qué tan protegidos estamos?</a:t>
             </a:r>
           </a:p>
         </p:txBody>
@@ -24257,7 +24268,7 @@
                 </a:solidFill>
                 <a:latin typeface="Calibri"/>
               </a:rPr>
-              <a:t>Captura del Test Runner con los 7 tests en verde junto al badge de cobertura «65,5 %» del reporte del proyecto.</a:t>
+              <a:t>Captura del Test Runner con los 7 tests en verde junto al resumen del reporte de cobertura regenerado (73,6 % de líneas).</a:t>
             </a:r>
           </a:p>
         </p:txBody>

</xml_diff>

<commit_message>
docs(clase): rewrite speaker notes of integration testing II slides
- Remove all timings from speaker notes (timing stays on the agenda slide)
- Add brief theory and clarifications for each slide: what it covers,
  background concept, and explanation of each point, keeping verified data
- Move notes to docs/clase-integracion-2/notas.py, indexed by slide title;
  the generator fails if a slide has no note

Co-Authored-By: Claude Opus 5.5 <noreply@anthropic.com>
</commit_message>
<xml_diff>
--- a/docs/clase-integracion-2/Testing-Integracion-II.pptx
+++ b/docs/clase-integracion-2/Testing-Integracion-II.pptx
@@ -528,7 +528,22 @@
           <a:lstStyle/>
           <a:p>
             <a:r>
-              <a:t>Portada. Misma base que la clase anterior: el proyecto nave + asteroides y su TestSuite de 7 tests.</a:t>
+              <a:t>QUÉ SE TOCA: presentación de la clase y continuidad con «Testing de integración».</a:t>
+            </a:r>
+          </a:p>
+          <a:p>
+            <a:r>
+              <a:t>CONTEXTO: seguimos con el proyecto nave + asteroides (Crashteroids, basado en el tutorial de Kodeco) y su TestSuite de 7 tests de Play Mode.</a:t>
+            </a:r>
+          </a:p>
+          <a:p>
+            <a:r>
+              <a:t>OBJETIVO DE LA CLASE: no se trata de escribir más tests por escribirlos, sino de pasar de una colección de tests a una estrategia: qué probar, cómo aislar cada test, cómo saber si los resultados son confiables y cómo organizar la suite.</a:t>
+            </a:r>
+          </a:p>
+          <a:p>
+            <a:r>
+              <a:t>IDEA PARA ABRIR: una suite en verde no es lo mismo que un juego sin defectos. Es uno de los 7 principios del testing (Unidad I): las pruebas muestran la presencia de defectos, no su ausencia.</a:t>
             </a:r>
           </a:p>
         </p:txBody>
@@ -598,7 +613,37 @@
           <a:lstStyle/>
           <a:p>
             <a:r>
-              <a:t>5 min. Puntos de discusión: (1) el flujo B ya tiene positivos (02 y 04): aceptar que un grupo proponga 'GameOver muestra el texto de Game Over' (gameOverText, Game.cs 64) como positivo válido; (2) INT-AST-08 reemplaza con ventaja a 03, que simula el Game Over poniendo isGameOver = true a mano: un estado que el juego nunca produce así; (3) INT-AST-10 necesita un objeto de prueba (un cubo con collider) que no existe en el juego: primer ejemplo de dato de prueba artificial. Verificado: el prefab Laser tiene Rigidbody dinámico y BoxCollider, así que un cubo con solo un collider alcanza para que ocurra OnCollisionEnter.</a:t>
+              <a:t>QUÉ SE TOCA: la resolución de la Actividad 1.</a:t>
+            </a:r>
+          </a:p>
+          <a:p>
+            <a:r>
+              <a:t>PUNTOS A REMARCAR:</a:t>
+            </a:r>
+          </a:p>
+          <a:p>
+            <a:r>
+              <a:t>(1) El flujo B ya tiene positivos (02 y 04). Si un grupo propone «el Game Over muestra el texto de Game Over» (gameOverText, Game.cs 64), es un positivo válido.</a:t>
+            </a:r>
+          </a:p>
+          <a:p>
+            <a:r>
+              <a:t>(2) INT-AST-08 reemplaza con ventaja al 03: el 03 simula el Game Over con isGameOver = true, un estado artificial; el 08 llega al Game Over por el camino real (un choque), como un jugador.</a:t>
+            </a:r>
+          </a:p>
+          <a:p>
+            <a:r>
+              <a:t>(3) INT-AST-10 necesita un objeto que no existe en el juego (un cubo con collider): es el primer ejemplo de dato de prueba artificial, un «dummy» (se retoma en el Bloque 3).</a:t>
+            </a:r>
+          </a:p>
+          <a:p>
+            <a:r>
+              <a:t>(4) El caso C− (llamar a NewGame con una partida en curso) conecta con INT-AST-15.</a:t>
+            </a:r>
+          </a:p>
+          <a:p>
+            <a:r>
+              <a:t>DATOS VERIFICADOS: el prefab Laser tiene Rigidbody dinámico y BoxCollider, así que alcanza con un cubo con collider para que ocurra OnCollisionEnter. El ScoreText está dentro del prefab Game (UICanvas), así que INT-AST-09 se puede automatizar sin cambiar el código del juego.</a:t>
             </a:r>
           </a:p>
         </p:txBody>
@@ -668,7 +713,22 @@
           <a:lstStyle/>
           <a:p>
             <a:r>
-              <a:t>Objetivo: aplicar valores frontera a interacciones. Resultado esperado: 5 filas con valores concretos y al menos 2 filas marcadas ⚠. Discusión: diferencia entre un borde con respuesta en el código (y = −5) y uno que requiere decisión de diseño (un láser contra dos asteroides).</a:t>
+              <a:t>OBJETIVO: aplicar el análisis de valores frontera a interacciones entre componentes.</a:t>
+            </a:r>
+          </a:p>
+          <a:p>
+            <a:r>
+              <a:t>CÓMO GUIAR: pedir valores concretos (−4,99; −5,00; −5,01), no «valores cercanos al límite». Para la dimensión tiempo, recordar que el cooldown del disparo es de 0,4 s.</a:t>
+            </a:r>
+          </a:p>
+          <a:p>
+            <a:r>
+              <a:t>RESULTADO ESPERADO: 5 filas con valores concretos y al menos 2 marcadas con ⚠.</a:t>
+            </a:r>
+          </a:p>
+          <a:p>
+            <a:r>
+              <a:t>PREGUNTAS PARA LA DISCUSIÓN: ¿qué diferencia hay entre un borde que se responde leyendo el código (y = −5) y uno que requiere una decisión de diseño (un láser contra dos asteroides)? ¿Quién decide el resultado esperado de una fila ⚠? Respuesta: el diseño o el responsable del producto; quien prueba lo registra como pregunta.</a:t>
             </a:r>
           </a:p>
         </p:txBody>
@@ -738,7 +798,32 @@
           <a:lstStyle/>
           <a:p>
             <a:r>
-              <a:t>5 min. Las filas ⚠ no se resuelven por inferencia: se registran como pregunta al diseño y el caso queda pendiente hasta tener respuesta. Resultados reales (Unity 6000.3.11f1, batchmode, 28/09/2026, Assets/Tests/IntegrationHypothesesTests.cs). INT-AST-13: FAIL con «Unhandled log message: InvalidOperationException: Trying to release an object that has already been released to the pool», lanzada en Laser.cs:52; en una corrida de diagnóstico que ignoraba ese error, el score quedó en 2. Causa: los dos OnCollisionEnter corren antes de que Destroy se haga efectivo. INT-AST-15: con una llamada a NewGame aparecen 5 asteroides en 2,1 s; con dos llamadas seguidas, 8 (nave alejada para evitar un Game Over que detendría el spawner). Causa: StartCoroutine sobre el mismo IEnumerator (Spawner.cs 49–62).</a:t>
+              <a:t>QUÉ SE TOCA: la resolución de la Actividad 2 y los resultados reales de dos casos borde.</a:t>
+            </a:r>
+          </a:p>
+          <a:p>
+            <a:r>
+              <a:t>TEORÍA: el resultado esperado sale de la especificación o del diseño, no de lo que hace el código hoy. Si la especificación no lo dice, el caso queda pendiente y se registra la pregunta; no se resuelve por inferencia.</a:t>
+            </a:r>
+          </a:p>
+          <a:p>
+            <a:r>
+              <a:t>ACLARACIONES POR FILA: Valor: la condición es estricta (y &lt; −5), así que en −5,00 el asteroide sigue vivo. Tiempo: hoy no se puede automatizar porque la regla del cooldown depende del teclado (ver Bloque 3).</a:t>
+            </a:r>
+          </a:p>
+          <a:p>
+            <a:r>
+              <a:t>RESULTADOS REALES (Unity 6000.3.11f1, batchmode, Assets/Tests/IntegrationHypothesesTests.cs):</a:t>
+            </a:r>
+          </a:p>
+          <a:p>
+            <a:r>
+              <a:t>- INT-AST-13: FALLA con «InvalidOperationException: Trying to release an object that has already been released to the pool» en Laser.cs:52. En una corrida de diagnóstico que ignoraba la excepción, el puntaje quedó en 2. Causa: los dos OnCollisionEnter se ejecutan antes de que Destroy se haga efectivo.</a:t>
+            </a:r>
+          </a:p>
+          <a:p>
+            <a:r>
+              <a:t>- INT-AST-15: FALLA. 5 asteroides en 2,1 s con una llamada a NewGame; 8 con dos llamadas seguidas (con la nave alejada para evitar un Game Over). Causa: StartCoroutine sobre el mismo IEnumerator (Spawner.cs 49–62).</a:t>
             </a:r>
           </a:p>
         </p:txBody>
@@ -808,7 +893,42 @@
           <a:lstStyle/>
           <a:p>
             <a:r>
-              <a:t>4 min. Idea clave: aislamiento = cada test puede correr solo y en cualquier orden con el mismo resultado. Los tres problemas son reales en el código; su efecto concreto depende del orden de ejecución (ver la diapositiva de tests frágiles).</a:t>
+              <a:t>QUÉ SE TOCA: qué es una fixture y por qué la suite actual no aísla los tests.</a:t>
+            </a:r>
+          </a:p>
+          <a:p>
+            <a:r>
+              <a:t>TEORÍA: una fixture es el estado conocido desde el que arranca cada test (SetUp) más la limpieza al terminar (TearDown). Su objetivo es el aislamiento: cada test tiene que poder correr solo y en cualquier orden con el mismo resultado. Si un test depende de lo que dejó otro, un fallo puede aparecer o desaparecer según el orden de ejecución.</a:t>
+            </a:r>
+          </a:p>
+          <a:p>
+            <a:r>
+              <a:t>Los datos de prueba son valores y objetos preparados a propósito, y deben ser reproducibles: si hay azar, se controla con una semilla.</a:t>
+            </a:r>
+          </a:p>
+          <a:p>
+            <a:r>
+              <a:t>ACLARACIONES — los tres problemas de la suite actual:</a:t>
+            </a:r>
+          </a:p>
+          <a:p>
+            <a:r>
+              <a:t>(1) Objetos que sobreviven: Spawner.SpawnAsteroid y Ship.SpawnLaser usan Instantiate sin padre, así que quedan como objetos raíz y el TearDown (que solo destruye el prefab Game) no los alcanza.</a:t>
+            </a:r>
+          </a:p>
+          <a:p>
+            <a:r>
+              <a:t>(2) Estado estático: Game.instance es static; hasta que corre el Start() del test nuevo, apunta al Game destruido del test anterior.</a:t>
+            </a:r>
+          </a:p>
+          <a:p>
+            <a:r>
+              <a:t>(3) Azar: el Spawner usa Random.Range sin semilla.</a:t>
+            </a:r>
+          </a:p>
+          <a:p>
+            <a:r>
+              <a:t>Su efecto concreto depende del orden de ejecución (ver la diapositiva de tests frágiles).</a:t>
             </a:r>
           </a:p>
         </p:txBody>
@@ -878,7 +998,47 @@
           <a:lstStyle/>
           <a:p>
             <a:r>
-              <a:t>Demo de 5 min comparando con TestSuite.cs 40–51. [UnitySetUp] y [UnityTearDown] son atributos del Unity Test Framework que permiten usar yield. FindObjectsByType por defecto ignora objetos inactivos: la plantilla inactiva del láser, si está dentro del prefab, no se toca. Evidencia: una limpieza equivalente se usa en Assets/Tests/IntegrationHypothesesTests.cs y corrió en batchmode el 28/09/2026. La parte de Random.InitState no se ejecutó: su estado es UNKNOWN.</a:t>
+              <a:t>QUÉ SE TOCA: una fixture que resuelve los tres problemas de la diapositiva anterior.</a:t>
+            </a:r>
+          </a:p>
+          <a:p>
+            <a:r>
+              <a:t>TEORÍA: [UnitySetUp] y [UnityTearDown] son la versión de SetUp y TearDown del Unity Test Framework que permite usar yield, es decir, esperar frames. Hace falta porque Start() recién se ejecuta en el frame siguiente a Instantiate, y Destroy() recién se completa después del ciclo de actualización.</a:t>
+            </a:r>
+          </a:p>
+          <a:p>
+            <a:r>
+              <a:t>ACLARACIONES — línea por línea:</a:t>
+            </a:r>
+          </a:p>
+          <a:p>
+            <a:r>
+              <a:t>- Random.InitState fija la semilla: mismas posiciones en cada corrida.</a:t>
+            </a:r>
+          </a:p>
+          <a:p>
+            <a:r>
+              <a:t>- El primer yield return null deja correr Start(): Game.instance queda asignado.</a:t>
+            </a:r>
+          </a:p>
+          <a:p>
+            <a:r>
+              <a:t>- El TearDown destruye también asteroides y láseres.</a:t>
+            </a:r>
+          </a:p>
+          <a:p>
+            <a:r>
+              <a:t>- El último yield deja que Destroy se complete antes del test siguiente.</a:t>
+            </a:r>
+          </a:p>
+          <a:p>
+            <a:r>
+              <a:t>Detalle: FindObjectsByType ignora por defecto los objetos inactivos, así que no toca la plantilla inactiva del láser que está dentro del prefab.</a:t>
+            </a:r>
+          </a:p>
+          <a:p>
+            <a:r>
+              <a:t>EVIDENCIA: una limpieza equivalente se usa en IntegrationHypothesesTests.cs y corrió en batchmode. La semilla (Random.InitState) todavía no se ejecutó: su estado es UNKNOWN.</a:t>
             </a:r>
           </a:p>
         </p:txBody>
@@ -948,7 +1108,37 @@
           <a:lstStyle/>
           <a:p>
             <a:r>
-              <a:t>4 min. Ejemplo concreto (depende del orden, no confirmado ejecutando): el test 04 (TestSuite.cs 88–115) compara la cantidad de asteroides antes y después de esperar 0,5 s. Si un asteroide sobrante de un test anterior cae por debajo de y = −5 durante esa espera, el conteo baja y el test FALLA aunque el spawner se haya detenido → falso positivo. Al revés: si el spawner NO se detuvo pero en ese lapso uno sobrante se autodestruye, los conteos pueden coincidir y el test PASA → falso negativo. Fuente: martinfowler.com/articles/nonDeterminism.html.</a:t>
+              <a:t>QUÉ SE TOCA: qué es un test frágil, sus causas y un riesgo concreto de la suite.</a:t>
+            </a:r>
+          </a:p>
+          <a:p>
+            <a:r>
+              <a:t>TEORÍA: un test frágil (flaky) pasa o falla sin que cambie el código. Es grave porque destruye la confianza: cuando un test falla «a veces», el equipo empieza a ignorar los fallos, incluidos los reales. Causas típicas (Martin Fowler, «Eradicating Non-Determinism in Tests»): tiempo, estado compartido, orden, azar y recursos externos.</a:t>
+            </a:r>
+          </a:p>
+          <a:p>
+            <a:r>
+              <a:t>Terminología de la Unidad I: falso positivo = el test reporta un defecto que no existe; falso negativo = el test no detecta un defecto que sí existe.</a:t>
+            </a:r>
+          </a:p>
+          <a:p>
+            <a:r>
+              <a:t>ACLARACIONES — riesgo en la suite: el test 04 (TestSuite.cs 88–115) cuenta TODOS los asteroides de la escena antes y después de esperar 0,5 s.</a:t>
+            </a:r>
+          </a:p>
+          <a:p>
+            <a:r>
+              <a:t>- Si un asteroide sobrante de otro test cae por debajo de y = −5 durante la espera, el conteo baja y el test FALLA aunque el spawner se haya detenido: falso positivo.</a:t>
+            </a:r>
+          </a:p>
+          <a:p>
+            <a:r>
+              <a:t>- Si el spawner NO se detuvo pero en ese lapso un asteroide sobrante se autodestruye, los conteos pueden coincidir y el test PASA: falso negativo.</a:t>
+            </a:r>
+          </a:p>
+          <a:p>
+            <a:r>
+              <a:t>Este escenario depende del orden y de las posiciones, y no se confirmó ejecutándolo: presentarlo como un riesgo, no como un fallo observado.</a:t>
             </a:r>
           </a:p>
         </p:txBody>
@@ -1018,7 +1208,27 @@
           <a:lstStyle/>
           <a:p>
             <a:r>
-              <a:t>Detalle Unity: un GameObject destruido no es null de C#, pero «== null» devuelve true por la sobrecarga de UnityEngine.Object. NUnit Assert.IsNull(obj) puede no detectarlo; por eso Assert.IsTrue(obj == null).</a:t>
+              <a:t>QUÉ SE TOCA: cómo eliminar la causa «tiempo» de los tests frágiles.</a:t>
+            </a:r>
+          </a:p>
+          <a:p>
+            <a:r>
+              <a:t>TEORÍA: una espera fija (WaitForSeconds) apuesta a que «en X segundos ya pasó». En una máquina lenta o cargada la apuesta falla (falso positivo) y en una rápida se pierde tiempo. Una espera por condición con tiempo máximo termina apenas se cumple lo esperado y, si nunca se cumple, falla con un mensaje claro.</a:t>
+            </a:r>
+          </a:p>
+          <a:p>
+            <a:r>
+              <a:t>Para la física, la unidad de espera correcta es el paso de física: yield return new WaitForFixedUpdate().</a:t>
+            </a:r>
+          </a:p>
+          <a:p>
+            <a:r>
+              <a:t>ACLARACIONES: un GameObject destruido no es null para C#, pero «== null» devuelve true por la sobrecarga de UnityEngine.Object. El Assert.IsNull(obj) de NUnit puede no detectarlo; por eso se usa Assert.IsTrue(obj == null).</a:t>
+            </a:r>
+          </a:p>
+          <a:p>
+            <a:r>
+              <a:t>El mensaje del Assert explica qué se esperaba: cuando el test falla, ese mensaje es el primer dato del diagnóstico.</a:t>
             </a:r>
           </a:p>
         </p:txBody>
@@ -1088,7 +1298,37 @@
           <a:lstStyle/>
           <a:p>
             <a:r>
-              <a:t>La salida es REAL: Unity 6000.3.11f1 en batchmode, 28/09/2026, test en Assets/Tests/IntegrationHypothesesTests.cs. La primera línea (yield return null) es necesaria: sin ella, Game.GameOver() se ejecuta antes de que Start() asigne Game.instance. Objetivo: practicar el análisis de causa raíz de un fallo de integración. Resultado esperado: una cadena causal con archivo y líneas, más un ticket. Discusión: ¿cómo sabemos que el resultado esperado es correcto? (ver resolución).</a:t>
+              <a:t>OBJETIVO: analizar la causa raíz de un fallo de integración.</a:t>
+            </a:r>
+          </a:p>
+          <a:p>
+            <a:r>
+              <a:t>TEORÍA: ante un test en rojo hay dos hipótesis iniciales: falla el juego o falla el test. Antes de levantar un ticket hay que descartar la segunda: ¿el test prepara bien el escenario? ¿El resultado esperado está respaldado por el diseño?</a:t>
+            </a:r>
+          </a:p>
+          <a:p>
+            <a:r>
+              <a:t>CÓMO GUIAR: seguir la cadena desde el assert hacia atrás: ¿qué objeto se esperaba destruido? ¿Qué método debía destruirlo? ¿Qué hace realmente ese método?</a:t>
+            </a:r>
+          </a:p>
+          <a:p>
+            <a:r>
+              <a:t>LA SALIDA ES REAL: Unity 6000.3.11f1 en batchmode; test en Assets/Tests/IntegrationHypothesesTests.cs.</a:t>
+            </a:r>
+          </a:p>
+          <a:p>
+            <a:r>
+              <a:t>ACLARACIÓN: la primera línea (yield return null) es necesaria. Sin ella, Game.GameOver() se ejecuta antes de que Start() asigne Game.instance y el test fallaría por un motivo ajeno a lo que se quiere probar: sería un error del test, no del juego.</a:t>
+            </a:r>
+          </a:p>
+          <a:p>
+            <a:r>
+              <a:t>RESULTADO ESPERADO: una cadena causal con archivo y líneas, y un ticket.</a:t>
+            </a:r>
+          </a:p>
+          <a:p>
+            <a:r>
+              <a:t>PREGUNTA PARA LA DISCUSIÓN: ¿cómo sabemos que el resultado esperado es correcto?</a:t>
             </a:r>
           </a:p>
         </p:txBody>
@@ -1158,7 +1398,47 @@
           <a:lstStyle/>
           <a:p>
             <a:r>
-              <a:t>5 min. Confirmado ejecutando (FAIL, Expected True / But was False). (1) ¿Juego o test? El test está bien construido: el asteroide está lejos de la nave, el spawner automático recién crea uno nuevo a los 0,4 s y se espera 1 frame. El nombre ClearAsteroids sugiere la intención, pero NO inferir el requisito: confirmarlo con diseño. Si el diseño dijera que los asteroides deben seguir cayendo, el que está mal es el test. (2) Causa: el pool se construye con SpawnAsteroid como función de creación (Spawner.cs 52–53) pero nunca se llama a Get(); SpawnAsteroid se usa directo. Laser.cs 52 hace Release de objetos que nunca se pidieron al pool. (3) Impacto: con un reinicio rápido, un asteroide viejo puede chocar la nave en (0,0,0) → Game Over inmediato. (4) Ticket con pasos, esperado/actual y evidencia (salida del test). (5) Regresión: el test queda en rojo hasta el arreglo y luego protege contra la reaparición del defecto.</a:t>
+              <a:t>QUÉ SE TOCA: la resolución de la Actividad 3.</a:t>
+            </a:r>
+          </a:p>
+          <a:p>
+            <a:r>
+              <a:t>TEORÍA: la causa raíz (Unidad I) es el origen del defecto, no su síntoma. El síntoma es «el asteroide sobrevive al reinicio»; la causa es «el pool de asteroides no se usa de forma consistente».</a:t>
+            </a:r>
+          </a:p>
+          <a:p>
+            <a:r>
+              <a:t>RESOLUCIÓN:</a:t>
+            </a:r>
+          </a:p>
+          <a:p>
+            <a:r>
+              <a:t>(1) ¿Juego o test? El test está bien construido: el asteroide está lejos de la nave, el spawner automático recién crea uno nuevo a los 0,4 s y se espera un solo frame. El nombre ClearAsteroids sugiere la intención, pero el requisito no se infiere: se confirma con diseño. Si el diseño dijera que los asteroides deben seguir cayendo, el que está mal es el test.</a:t>
+            </a:r>
+          </a:p>
+          <a:p>
+            <a:r>
+              <a:t>(2) Causa: el pool se crea con SpawnAsteroid como función de creación (Spawner.cs 52–53), pero nunca se llama a Get(): SpawnAsteroid se usa directamente con Instantiate. ClearAsteroids llama a Dispose(), que vacía un pool que no contiene los asteroides en pantalla. Además, Laser.cs 52 hace Release de objetos que nunca se pidieron al pool: es la misma raíz del fallo de INT-AST-13.</a:t>
+            </a:r>
+          </a:p>
+          <a:p>
+            <a:r>
+              <a:t>(3) Impacto para el jugador: con un reinicio rápido, un asteroide viejo puede chocar la nave recién reparada en (0,0,0) y provocar un Game Over inmediato.</a:t>
+            </a:r>
+          </a:p>
+          <a:p>
+            <a:r>
+              <a:t>(4) Ticket: título, pasos, esperado/actual, evidencia (salida del test), severidad y prioridad.</a:t>
+            </a:r>
+          </a:p>
+          <a:p>
+            <a:r>
+              <a:t>(5) Regresión: el test queda en rojo hasta el arreglo y después protege contra la reaparición del defecto.</a:t>
+            </a:r>
+          </a:p>
+          <a:p>
+            <a:r>
+              <a:t>ACLARACIÓN: destruir los asteroides en ClearAsteroids resuelve INT-AST-14, pero no el doble Release de INT-AST-13. Arreglar el uso del pool ataca la causa común.</a:t>
             </a:r>
           </a:p>
         </p:txBody>
@@ -1228,7 +1508,82 @@
           <a:lstStyle/>
           <a:p>
             <a:r>
-              <a:t>6 min. Advertencia: con demasiados dobles, el test deja de ser de integración y se vuelve unitario. Dependencias reales del proyecto y su estrategia: Input (Ship.cs 61–71) → reemplazar o evitar; Random (Spawner.cs 75, 103) → controlar con semilla, sin doble; tiempo (corrutinas de 0,4 s) → esperar por condición; física → WaitForFixedUpdate; estado estático (Game.instance) → fixture. El proyecto no tiene sistemas externos (red, archivos, tiendas): ese tema queda para una clase futura. Fuente: martinfowler.com/bliki/TestDouble.html.</a:t>
+              <a:t>QUÉ SE TOCA: los tipos de dobles de prueba y cuándo usarlos en integración.</a:t>
+            </a:r>
+          </a:p>
+          <a:p>
+            <a:r>
+              <a:t>TEORÍA: un doble de prueba (test double, término de Gerard Meszaros difundido por Martin Fowler) reemplaza a un colaborador real durante el test.</a:t>
+            </a:r>
+          </a:p>
+          <a:p>
+            <a:r>
+              <a:t>- Dummy: solo ocupa un lugar.</a:t>
+            </a:r>
+          </a:p>
+          <a:p>
+            <a:r>
+              <a:t>- Stub: devuelve respuestas fijas.</a:t>
+            </a:r>
+          </a:p>
+          <a:p>
+            <a:r>
+              <a:t>- Spy: registra cómo se lo usó, para revisarlo después.</a:t>
+            </a:r>
+          </a:p>
+          <a:p>
+            <a:r>
+              <a:t>- Mock: tiene expectativas programadas y falla si no se cumplen.</a:t>
+            </a:r>
+          </a:p>
+          <a:p>
+            <a:r>
+              <a:t>- Fake: implementación simplificada pero que funciona.</a:t>
+            </a:r>
+          </a:p>
+          <a:p>
+            <a:r>
+              <a:t>REGLA PARA INTEGRACIÓN: lo que está en la costura que se quiere probar va REAL; se reemplaza solo lo no determinista o lo que queda fuera de alcance. Con demasiados dobles, el test deja de ser de integración y se vuelve unitario.</a:t>
+            </a:r>
+          </a:p>
+          <a:p>
+            <a:r>
+              <a:t>ACLARACIONES — dependencias reales del proyecto y su estrategia:</a:t>
+            </a:r>
+          </a:p>
+          <a:p>
+            <a:r>
+              <a:t>- Entrada (Ship.cs 61–71): reemplazar con un stub o evitarla.</a:t>
+            </a:r>
+          </a:p>
+          <a:p>
+            <a:r>
+              <a:t>- Azar (Spawner.cs 75 y 103): controlar con una semilla, sin doble.</a:t>
+            </a:r>
+          </a:p>
+          <a:p>
+            <a:r>
+              <a:t>- Tiempo (corrutinas de 0,4 s): esperar por condición.</a:t>
+            </a:r>
+          </a:p>
+          <a:p>
+            <a:r>
+              <a:t>- Física: WaitForFixedUpdate.</a:t>
+            </a:r>
+          </a:p>
+          <a:p>
+            <a:r>
+              <a:t>- Estado estático (Game.instance): resolver con la fixture.</a:t>
+            </a:r>
+          </a:p>
+          <a:p>
+            <a:r>
+              <a:t>Varios ejemplos de la tabla son PROPUESTA: Game usa métodos estáticos (GameOver, AsteroidDestroyed), que no se pueden reemplazar por un doble sin modificar el código.</a:t>
+            </a:r>
+          </a:p>
+          <a:p>
+            <a:r>
+              <a:t>El proyecto no tiene sistemas externos (red, archivos, tiendas); ese tema queda para una clase futura.</a:t>
             </a:r>
           </a:p>
         </p:txBody>
@@ -1298,7 +1653,42 @@
           <a:lstStyle/>
           <a:p>
             <a:r>
-              <a:t>3 min. Ya se trabajó en la clase anterior: niveles vs. tipos, Play Mode ≠ integración, clasificación de estos 7 tests, el hueco del HUD (score vs. scoreText) y las esperas fijas. NO repetir: se usa como punto de partida. Huecos que abre esta clase: (1) no hay negativos ni bordes; (2) 03 parte de un Game Over falso (isGameOver = true a mano); (3) los tests no limpian asteroides ni láseres; (4) nada ejercita la entrada del jugador.</a:t>
+              <a:t>QUÉ SE TOCA: el punto de partida; qué cubren los 7 tests y qué dejan afuera.</a:t>
+            </a:r>
+          </a:p>
+          <a:p>
+            <a:r>
+              <a:t>REPASO (no reexplicar): en la clase anterior se vieron niveles vs. tipos de prueba, que Play Mode es un modo de ejecución y no un nivel, la clasificación de estos 7 tests y dos límites: el texto del HUD no se verifica y las esperas son fijas.</a:t>
+            </a:r>
+          </a:p>
+          <a:p>
+            <a:r>
+              <a:t>TEORÍA: una suite se evalúa por lo que deja afuera, no solo por lo que pasa. Tres preguntas para cualquier suite: ¿prueba lo que NO debe pasar? ¿prueba los límites? ¿cada test es independiente de los demás?</a:t>
+            </a:r>
+          </a:p>
+          <a:p>
+            <a:r>
+              <a:t>ACLARACIONES — huecos que abre esta clase:</a:t>
+            </a:r>
+          </a:p>
+          <a:p>
+            <a:r>
+              <a:t>(1) Los 7 son casos positivos: no hay negativos ni bordes.</a:t>
+            </a:r>
+          </a:p>
+          <a:p>
+            <a:r>
+              <a:t>(2) El test 03 parte de un Game Over falso: pone isGameOver = true a mano, un estado que el juego nunca produce así.</a:t>
+            </a:r>
+          </a:p>
+          <a:p>
+            <a:r>
+              <a:t>(3) El TearDown solo destruye el prefab Game: asteroides y láseres quedan en escena para el test siguiente.</a:t>
+            </a:r>
+          </a:p>
+          <a:p>
+            <a:r>
+              <a:t>(4) Ningún test ejercita la entrada del jugador.</a:t>
             </a:r>
           </a:p>
         </p:txBody>
@@ -1368,7 +1758,27 @@
           <a:lstStyle/>
           <a:p>
             <a:r>
-              <a:t>2 min de demo del problema + discusión. Conecta con la clase de plataformas: la misma separación de la entrada que permite portar a móvil permite testear la regla. Verificado en Packages/manifest.json: el proyecto NO tiene el paquete Input System. No instalarlo sin autorización. En el reporte regenerado, Ship.cs 61–74 no se ejecuta: durante los frames de los tests la nave está «muerta» (isDead empieza en true y solo RepairShip lo cambia), así que Update sale en la línea 57.</a:t>
+              <a:t>QUÉ SE TOCA: una regla de juego que no se puede probar por cómo está escrita.</a:t>
+            </a:r>
+          </a:p>
+          <a:p>
+            <a:r>
+              <a:t>TEORÍA: una regla de juego es testeable cuando se puede ejecutar sin su fuente de entrada real. Si la regla está mezclada con la lectura del dispositivo, para probarla hay que simular el dispositivo. Separar «qué quiere hacer el jugador» de «cómo lo pide» crea una costura (seam) donde se puede enchufar un stub.</a:t>
+            </a:r>
+          </a:p>
+          <a:p>
+            <a:r>
+              <a:t>ACLARACIONES: la regla (canShoot) se evalúa en Update junto a Input.GetKey (Ship.cs 61). ShootLaser (77–80) no la respeta: dos llamadas seguidas crean dos láseres. Respuesta a la pregunta: 3 láseres en 1 s (t = 0; 0,4; 0,8).</a:t>
+            </a:r>
+          </a:p>
+          <a:p>
+            <a:r>
+              <a:t>Conexión con la clase de plataformas: la misma separación de la entrada que permite portar el juego a móvil es la que permite testear la regla.</a:t>
+            </a:r>
+          </a:p>
+          <a:p>
+            <a:r>
+              <a:t>DATOS VERIFICADOS: Packages/manifest.json no incluye el paquete Input System, así que la opción A requiere instalarlo (no hacerlo sin autorización). En el reporte regenerado, Ship.cs 61–74 no se ejecuta nunca: durante los tests la nave está «muerta» (isDead empieza en true y solo RepairShip lo cambia), así que Update termina en la línea 57.</a:t>
             </a:r>
           </a:p>
         </p:txBody>
@@ -1438,7 +1848,52 @@
           <a:lstStyle/>
           <a:p>
             <a:r>
-              <a:t>5 min + 3 de demo abriendo el reporte. Reporte VIEJO (Asteroides/asteroide-final/CodeCoverage): 'MultiReportParser (6x OpenCoverParser)', 3 carpetas de resultados (cada corrida genera 2 XML), incluye el assembly de tests y reporta 644 líneas coverables sobre 616 totales; su vista línea por línea corresponde a una corrida con un solo test. Reporte REGENERADO (Unity 6000.3.11f1, batchmode, 28/09/2026, -testFilter TestSuite, assemblyFilters:+GameAssembly, carpeta limpia fuera del repo): 7/7 PASS; 137 de 186 líneas (73,6 %); 27 de 31 métodos (87 %); Asteroid 84,2 %, Game 100 %, Laser 81,2 %, Ship 43 %, Spawner 86,9 %. Sin cubrir: Ship 61–74 (la nave está muerta durante los frames de los tests), Ship 99–115 (MoveLeft/MoveRight), Asteroid 48 (destrucción bajo y = −5), Spawner 69 (spawn automático), Laser 42 (láser fuera de pantalla). Game.cs 85 figura cubierta (2 visitas, tests 06 y 07) aunque ningún assert la verifica. Paquete: Code Coverage 1.3 (docs.unity3d.com/Packages/com.unity.testtools.codecoverage@1.3).</a:t>
+              <a:t>QUÉ SE TOCA: cómo leer un reporte de cobertura sin sobreestimarlo.</a:t>
+            </a:r>
+          </a:p>
+          <a:p>
+            <a:r>
+              <a:t>TEORÍA: la cobertura de código mide qué líneas (o métodos, o ramas) se EJECUTARON durante los tests. No mide si algún assert verificó su efecto. Sirve para encontrar código que ningún test toca; no sirve para afirmar que el código está bien probado.</a:t>
+            </a:r>
+          </a:p>
+          <a:p>
+            <a:r>
+              <a:t>Cobertura de líneas ≠ cobertura de ramas: una línea con un if puede ejecutarse sin recorrer sus dos salidas.</a:t>
+            </a:r>
+          </a:p>
+          <a:p>
+            <a:r>
+              <a:t>Para leer un reporte hay que saber de qué corrida viene: qué tests, qué assemblies y qué fecha.</a:t>
+            </a:r>
+          </a:p>
+          <a:p>
+            <a:r>
+              <a:t>ACLARACIONES:</a:t>
+            </a:r>
+          </a:p>
+          <a:p>
+            <a:r>
+              <a:t>- Reporte VIEJO (Asteroides/asteroide-final/CodeCoverage): combinaba 6 archivos de 3 carpetas de resultados (15/09 y 18/09), incluía el código de los tests y su vista línea por línea correspondía a una corrida de un solo test. Su 65,5 % no describía la suite.</a:t>
+            </a:r>
+          </a:p>
+          <a:p>
+            <a:r>
+              <a:t>- Reporte REGENERADO (7/7 PASS, solo GameAssembly, carpeta limpia): 137 de 186 líneas (73,6 %) y 27 de 31 métodos (87 %). Asteroid 84,2 %, Game 100 %, Laser 81,2 %, Ship 43 %, Spawner 86,9 %.</a:t>
+            </a:r>
+          </a:p>
+          <a:p>
+            <a:r>
+              <a:t>- Sin cubrir: Ship 61–74 (entrada) y 99–115 (movimiento lateral); Asteroid 48 (destrucción bajo y = −5); Spawner 69 (spawn automático); Laser 42 (láser fuera de pantalla).</a:t>
+            </a:r>
+          </a:p>
+          <a:p>
+            <a:r>
+              <a:t>- Respuesta a la pregunta: Game.cs tiene 100 %, pero la línea 85 (texto del HUD) se ejecuta en los tests 06 y 07 sin que ningún assert la compruebe. 100 % de cobertura no es 100 % verificado.</a:t>
+            </a:r>
+          </a:p>
+          <a:p>
+            <a:r>
+              <a:t>Paquete usado: Code Coverage 1.3.</a:t>
             </a:r>
           </a:p>
         </p:txBody>
@@ -1508,7 +1963,22 @@
           <a:lstStyle/>
           <a:p>
             <a:r>
-              <a:t>3 min. Un test de regresión que nunca se vio en rojo no demuestra que detecta el defecto: por eso primero se lo ve fallar.</a:t>
+              <a:t>QUÉ SE TOCA: el ciclo que convierte un defecto encontrado en protección permanente.</a:t>
+            </a:r>
+          </a:p>
+          <a:p>
+            <a:r>
+              <a:t>TEORÍA (Unidad II): retesting = volver a probar el arreglo de un defecto concreto. Testing de regresión = volver a probar lo que ya funcionaba para detectar si un cambio lo rompió. Un test automatizado que nace de un bug cumple las dos funciones: primero confirma el arreglo y después queda vigilando.</a:t>
+            </a:r>
+          </a:p>
+          <a:p>
+            <a:r>
+              <a:t>ACLARACIONES: el orden importa. El test se ve primero en ROJO, con el defecto presente: esa es la prueba de que es capaz de detectarlo. Un test de regresión que nunca se vio fallar puede estar pasando por la razón equivocada (por ejemplo, porque no prepara bien el escenario).</a:t>
+            </a:r>
+          </a:p>
+          <a:p>
+            <a:r>
+              <a:t>APLICACIÓN: INT-AST-13, 14 y 15 ya están en rojo en IntegrationHypothesesTests.cs. Cuando se corrijan los defectos pasarán a verde y quedarán en la suite.</a:t>
             </a:r>
           </a:p>
         </p:txBody>
@@ -1578,7 +2048,47 @@
           <a:lstStyle/>
           <a:p>
             <a:r>
-              <a:t>Objetivo: priorizar y organizar, no escribir código. Resultado esperado: una tabla de ≤12 tests con justificación. Discusión: ¿fusionar dos tests mejora o empeora el diagnóstico cuando uno falla? ¿Qué se corre en cada commit y qué de noche?</a:t>
+              <a:t>OBJETIVO: priorizar y organizar una suite, no escribir código.</a:t>
+            </a:r>
+          </a:p>
+          <a:p>
+            <a:r>
+              <a:t>TEORÍA: una suite es un producto con costo: tiempo de ejecución y mantenimiento. Se organiza por propósito:</a:t>
+            </a:r>
+          </a:p>
+          <a:p>
+            <a:r>
+              <a:t>- Smoke: pocos tests rápidos que verifican que lo esencial funciona; corren en cada cambio.</a:t>
+            </a:r>
+          </a:p>
+          <a:p>
+            <a:r>
+              <a:t>- Integración: los flujos principales entre componentes.</a:t>
+            </a:r>
+          </a:p>
+          <a:p>
+            <a:r>
+              <a:t>- Borde: los límites y los casos raros.</a:t>
+            </a:r>
+          </a:p>
+          <a:p>
+            <a:r>
+              <a:t>- Regresión: defectos ya encontrados que no deben volver.</a:t>
+            </a:r>
+          </a:p>
+          <a:p>
+            <a:r>
+              <a:t>En Unity se pueden etiquetar con [Category("Smoke")] y filtrar al ejecutar.</a:t>
+            </a:r>
+          </a:p>
+          <a:p>
+            <a:r>
+              <a:t>RESULTADO ESPERADO: una tabla de hasta 12 tests con categoría, momento de ejecución y decisión (queda / reescribir / fusionar / sale).</a:t>
+            </a:r>
+          </a:p>
+          <a:p>
+            <a:r>
+              <a:t>PREGUNTAS PARA LA DISCUSIÓN: ¿fusionar dos tests mejora o empeora el diagnóstico cuando uno falla? ¿Qué se corre en cada commit y qué de noche?</a:t>
             </a:r>
           </a:p>
         </p:txBody>
@@ -1648,7 +2158,47 @@
           <a:lstStyle/>
           <a:p>
             <a:r>
-              <a:t>5 min. Suite final: 11 tests. Justificaciones: 03 simula un Game Over que el juego no produce y 08 lo cubre con el flujo real; 07 queda absorbido por 09, que verifica el puntaje y el texto (contra: si falla 09 hay que mirar el mensaje del Assert para saber cuál de los dos falló); 01 y 05 verifican el movimiento de un componente: pueden ir a una carpeta de tests por componente. 13, 14 y 15 ya se ejecutaron y FALLAN: quedan en rojo como tests de regresión hasta que se corrijan los defectos. Criterio de independencia: cada test debe poder correr solo y en cualquier orden.</a:t>
+              <a:t>QUÉ SE TOCA: la resolución de la Actividad 4. Suite final: 11 tests.</a:t>
+            </a:r>
+          </a:p>
+          <a:p>
+            <a:r>
+              <a:t>ACLARACIONES — decisiones:</a:t>
+            </a:r>
+          </a:p>
+          <a:p>
+            <a:r>
+              <a:t>- El 03 sale: simula un Game Over que el juego no produce; el 08 cubre el mismo reinicio por el camino real.</a:t>
+            </a:r>
+          </a:p>
+          <a:p>
+            <a:r>
+              <a:t>- El 07 queda absorbido por el 09, que verifica el puntaje y el texto. En contra: si el 09 falla, hay que leer el mensaje del Assert para saber cuál de los dos efectos falló (se pierde granularidad).</a:t>
+            </a:r>
+          </a:p>
+          <a:p>
+            <a:r>
+              <a:t>- El 01 y el 05 verifican el movimiento de un solo componente: van a una carpeta de tests por componente, no a la de integración.</a:t>
+            </a:r>
+          </a:p>
+          <a:p>
+            <a:r>
+              <a:t>- El 04 se reescribe con la fixture de limpieza y contando solo los asteroides que crea el propio test.</a:t>
+            </a:r>
+          </a:p>
+          <a:p>
+            <a:r>
+              <a:t>- El 13, el 14 y el 15 ya se ejecutaron y FALLAN: quedan en rojo como regresión hasta que se corrijan los defectos.</a:t>
+            </a:r>
+          </a:p>
+          <a:p>
+            <a:r>
+              <a:t>- El 16 queda pendiente del refactor de la entrada.</a:t>
+            </a:r>
+          </a:p>
+          <a:p>
+            <a:r>
+              <a:t>CRITERIO GENERAL: independencia (cada test corre solo y en cualquier orden) y un nombre que diga qué flujo se prueba, en qué condición y con qué resultado: Flujo_Condición_Resultado.</a:t>
             </a:r>
           </a:p>
         </p:txBody>
@@ -1718,7 +2268,47 @@
           <a:lstStyle/>
           <a:p>
             <a:r>
-              <a:t>5 min. Si sobra tiempo: ¿qué test de la suite actual les da menos confianza y por qué?</a:t>
+              <a:t>QUÉ SE TOCA: las cinco ideas de la clase.</a:t>
+            </a:r>
+          </a:p>
+          <a:p>
+            <a:r>
+              <a:t>TEORÍA — resumen:</a:t>
+            </a:r>
+          </a:p>
+          <a:p>
+            <a:r>
+              <a:t>(1) Una suite solo de casos positivos no prueba lo que el juego NO debe hacer.</a:t>
+            </a:r>
+          </a:p>
+          <a:p>
+            <a:r>
+              <a:t>(2) En integración, el borde también es tiempo, cantidad, repetición y orden.</a:t>
+            </a:r>
+          </a:p>
+          <a:p>
+            <a:r>
+              <a:t>(3) Sin fixtures que limpien, los tests se contaminan entre sí y se vuelven frágiles.</a:t>
+            </a:r>
+          </a:p>
+          <a:p>
+            <a:r>
+              <a:t>(4) Los dobles de prueba se usan para lo que no está bajo prueba, no para todo.</a:t>
+            </a:r>
+          </a:p>
+          <a:p>
+            <a:r>
+              <a:t>(5) La cobertura dice qué se ejecutó, no qué se verificó.</a:t>
+            </a:r>
+          </a:p>
+          <a:p>
+            <a:r>
+              <a:t>ACTIVIDAD: el ticket de salida pide transferir lo aprendido a un juego propio: un caso negativo y uno de borde.</a:t>
+            </a:r>
+          </a:p>
+          <a:p>
+            <a:r>
+              <a:t>PREGUNTA EXTRA: ¿qué test de la suite actual les da menos confianza y por qué?</a:t>
             </a:r>
           </a:p>
         </p:txBody>
@@ -1788,7 +2378,22 @@
           <a:lstStyle/>
           <a:p>
             <a:r>
-              <a:t>Resultados de 13–15: 13 → excepción en Laser.cs:52 y score 2; 14 → el asteroide previo sobrevive; 15 → 8 asteroides con doble NewGame contra 5 con uno.</a:t>
+              <a:t>QUÉ SE TOCA: referencia rápida de los 9 casos nuevos.</a:t>
+            </a:r>
+          </a:p>
+          <a:p>
+            <a:r>
+              <a:t>ESTADOS: PROPUESTA = el caso está diseñado pero todavía no existe en el proyecto. EJECUTADO · FAIL = el test existe en Assets/Tests/IntegrationHypothesesTests.cs, se corrió en Unity 6000.3.11f1 (batchmode) y falla porque documenta un defecto real.</a:t>
+            </a:r>
+          </a:p>
+          <a:p>
+            <a:r>
+              <a:t>RESULTADOS: 13 → excepción en Laser.cs:52 y puntaje 2. 14 → el asteroide de la partida anterior sobrevive a NewGame. 15 → 8 asteroides en 2,1 s con doble NewGame, contra 5 con uno.</a:t>
+            </a:r>
+          </a:p>
+          <a:p>
+            <a:r>
+              <a:t>ACLARACIÓN: 13 y 14 comparten la raíz: el ObjectPool del Spawner no se usa de forma consistente (nunca se llama a Get()).</a:t>
             </a:r>
           </a:p>
         </p:txBody>
@@ -1858,7 +2463,47 @@
           <a:lstStyle/>
           <a:p>
             <a:r>
-              <a:t>Referencias verificadas (versiones del proyecto: Test Framework 1.6.0, Code Coverage 1.3.0): Unity Test Framework (docs.unity3d.com/Packages/com.unity.test-framework@1.6), Input System Testing (docs.unity3d.com/Packages/com.unity.inputsystem@1.11/manual/Testing.html), LogAssert (docs.unity3d.com/Packages/com.unity.test-framework@1.4/api/UnityEngine.TestTools.LogAssert.html), ObjectPool (docs.unity3d.com/ScriptReference/Pool.ObjectPool_1.html).</a:t>
+              <a:t>QUÉ SE TOCA: temas valiosos que no entran en esta clase.</a:t>
+            </a:r>
+          </a:p>
+          <a:p>
+            <a:r>
+              <a:t>ACLARACIONES:</a:t>
+            </a:r>
+          </a:p>
+          <a:p>
+            <a:r>
+              <a:t>- Sistemas externos (guardado del récord, tabla online): requieren fakes o entornos de prueba.</a:t>
+            </a:r>
+          </a:p>
+          <a:p>
+            <a:r>
+              <a:t>- Input System + InputTestFixture: permite simular teclado y táctil; requiere instalar el paquete.</a:t>
+            </a:r>
+          </a:p>
+          <a:p>
+            <a:r>
+              <a:t>- Tests parametrizados ([TestCase], [ValueSource]): evitan escribir un test por cada valor de borde.</a:t>
+            </a:r>
+          </a:p>
+          <a:p>
+            <a:r>
+              <a:t>- LogAssert: permite esperar o prohibir mensajes en el log (útil para INT-AST-13).</a:t>
+            </a:r>
+          </a:p>
+          <a:p>
+            <a:r>
+              <a:t>- Batchmode y CI: automatizan la ejecución en cada cambio.</a:t>
+            </a:r>
+          </a:p>
+          <a:p>
+            <a:r>
+              <a:t>- Cobertura de ramas: mide caminos, no solo líneas.</a:t>
+            </a:r>
+          </a:p>
+          <a:p>
+            <a:r>
+              <a:t>REFERENCIAS VERIFICADAS (versiones del proyecto: Test Framework 1.6.0, Code Coverage 1.3.0): docs.unity3d.com/Packages/com.unity.test-framework@1.6 · docs.unity3d.com/Packages/com.unity.inputsystem@1.11/manual/Testing.html · docs.unity3d.com/Packages/com.unity.test-framework@1.4/api/UnityEngine.TestTools.LogAssert.html · docs.unity3d.com/ScriptReference/Pool.ObjectPool_1.html · docs.unity3d.com/Packages/com.unity.testtools.codecoverage@1.3</a:t>
             </a:r>
           </a:p>
         </p:txBody>
@@ -1928,7 +2573,22 @@
           <a:lstStyle/>
           <a:p>
             <a:r>
-              <a:t>Los objetivos siguen el orden de los cuatro bloques de la clase.</a:t>
+              <a:t>QUÉ SE TOCA: los seis objetivos, en el mismo orden que los bloques.</a:t>
+            </a:r>
+          </a:p>
+          <a:p>
+            <a:r>
+              <a:t>ACLARACIONES — relación con los bloques: Bloque 1 → objetivo 1 (diseño de casos). Bloque 2 → objetivos 2 y 3 (fixtures y tests frágiles). Bloque 3 → objetivo 4 (dependencias y dobles de prueba). Bloque 4 → objetivos 5 y 6 (cobertura, regresión y organización de la suite).</a:t>
+            </a:r>
+          </a:p>
+          <a:p>
+            <a:r>
+              <a:t>TEORÍA: todos apuntan a una misma idea: la confianza en una suite depende de qué casos tiene, de que sus resultados sean reproducibles y de que se interprete bien lo que mide.</a:t>
+            </a:r>
+          </a:p>
+          <a:p>
+            <a:r>
+              <a:t>RELACIÓN CON EL PROGRAMA: Unidad I (partición de equivalencia, valores frontera, testing negativo, falsos positivos y negativos), Unidad II (regresión vs. retesting, casos de prueba, tickets) y Unidad III (Unity Test Framework, pruebas manuales vs. automatizadas).</a:t>
             </a:r>
           </a:p>
         </p:txBody>
@@ -1998,7 +2658,22 @@
           <a:lstStyle/>
           <a:p>
             <a:r>
-              <a:t>Proporción: ~31 % teoría, ~14 % demostración, ~38 % práctica, ~17 % resolución. Las resoluciones se hacen en plenario inmediatamente después de cada actividad.</a:t>
+              <a:t>QUÉ SE TOCA: la estructura de la clase.</a:t>
+            </a:r>
+          </a:p>
+          <a:p>
+            <a:r>
+              <a:t>ACLARACIONES: cada bloque sigue el mismo patrón: concepto → ejemplo simple → aplicación al juego → actividad con resolución.</a:t>
+            </a:r>
+          </a:p>
+          <a:p>
+            <a:r>
+              <a:t>Las resoluciones se hacen en plenario inmediatamente después de cada actividad, para corregir los errores mientras la consigna está fresca.</a:t>
+            </a:r>
+          </a:p>
+          <a:p>
+            <a:r>
+              <a:t>Las actividades 1, 2 y 4 son sin código. La 3 es de lectura y análisis de un test real del proyecto.</a:t>
             </a:r>
           </a:p>
         </p:txBody>
@@ -2068,7 +2743,47 @@
           <a:lstStyle/>
           <a:p>
             <a:r>
-              <a:t>5 min. Las cuatro preguntas son el mapa de la clase: 1 → Actividad 3 (INT-AST-14); 2 → Actividad 2 (INT-AST-13); 3 → Actividad 1 (INT-AST-11); 4 → Bloque 4 (cobertura). Datos reales: la suite de 7 tests se ejecutó en batchmode el 28/09/2026 (7/7 PASS) con cobertura en una carpeta limpia.</a:t>
+              <a:t>QUÉ SE TOCA: el problema que motiva la clase.</a:t>
+            </a:r>
+          </a:p>
+          <a:p>
+            <a:r>
+              <a:t>TEORÍA: «la suite pasa» solo dice que los casos que existen se comportan como se esperaba. Si no hay un caso para una situación, la suite no opina sobre ella. Por eso la pregunta correcta no es «¿pasa?» sino «¿qué situaciones prueba?».</a:t>
+            </a:r>
+          </a:p>
+          <a:p>
+            <a:r>
+              <a:t>ACLARACIONES — las cuatro preguntas son el mapa de la clase:</a:t>
+            </a:r>
+          </a:p>
+          <a:p>
+            <a:r>
+              <a:t>1 → Actividad 3 (INT-AST-14: reinicio con asteroides en pantalla).</a:t>
+            </a:r>
+          </a:p>
+          <a:p>
+            <a:r>
+              <a:t>2 → Actividad 2 (INT-AST-13: doble impacto).</a:t>
+            </a:r>
+          </a:p>
+          <a:p>
+            <a:r>
+              <a:t>3 → Actividad 1 (INT-AST-11: choque entre asteroides).</a:t>
+            </a:r>
+          </a:p>
+          <a:p>
+            <a:r>
+              <a:t>4 → Bloque 4 (cobertura).</a:t>
+            </a:r>
+          </a:p>
+          <a:p>
+            <a:r>
+              <a:t>Respuesta a la pregunta de la diapositiva: ninguna de las cuatro está cubierta hoy.</a:t>
+            </a:r>
+          </a:p>
+          <a:p>
+            <a:r>
+              <a:t>DATOS VERIFICADOS: la suite de 7 tests pasa completa (7/7) en Unity 6000.3.11f1 en batchmode. Cobertura regenerada en una carpeta limpia: 73,6 % de las líneas de GameAssembly; Game.cs, 100 %.</a:t>
             </a:r>
           </a:p>
         </p:txBody>
@@ -2138,7 +2853,42 @@
           <a:lstStyle/>
           <a:p>
             <a:r>
-              <a:t>4 min. Retoma partición de equivalencia y valores frontera (Unidad I) pero aplicados a interacciones entre componentes, no a un método aislado. Aclarar el error frecuente: 'caso negativo' no significa 'test que tiene que fallar'.</a:t>
+              <a:t>QUÉ SE TOCA: los tres tipos de caso y cómo se trasladan de un método a una interacción.</a:t>
+            </a:r>
+          </a:p>
+          <a:p>
+            <a:r>
+              <a:t>TEORÍA:</a:t>
+            </a:r>
+          </a:p>
+          <a:p>
+            <a:r>
+              <a:t>- Positivo: entrada válida → comportamiento esperado.</a:t>
+            </a:r>
+          </a:p>
+          <a:p>
+            <a:r>
+              <a:t>- Negativo (testing negativo, Unidad I): entrada inválida o no prevista → el sistema la ignora o la rechaza sin romperse.</a:t>
+            </a:r>
+          </a:p>
+          <a:p>
+            <a:r>
+              <a:t>- Borde: valores en el límite de una partición (análisis de valores frontera): justo antes, justo en y justo después del límite.</a:t>
+            </a:r>
+          </a:p>
+          <a:p>
+            <a:r>
+              <a:t>Estas técnicas nacieron para métodos con entradas numéricas. En integración se aplican a interacciones: qué colisiona con qué, cuándo y cuántas veces.</a:t>
+            </a:r>
+          </a:p>
+          <a:p>
+            <a:r>
+              <a:t>ACLARACIONES: error frecuente: «caso negativo» NO significa «test que tiene que fallar». El test de un caso negativo PASA cuando el sistema se comporta bien ante la entrada indebida. Ejemplo: un asteroide que choca con otro no debe dar Game Over; si no da Game Over, el test pasa.</a:t>
+            </a:r>
+          </a:p>
+          <a:p>
+            <a:r>
+              <a:t>EN EL JUEGO: Asteroid.cs 54 decide el Game Over comparando el nombre del objeto con «ShipModel». Esa condición define las particiones: «choques con la nave» y «choques con cualquier otra cosa».</a:t>
             </a:r>
           </a:p>
         </p:txBody>
@@ -2208,7 +2958,52 @@
           <a:lstStyle/>
           <a:p>
             <a:r>
-              <a:t>4 min + demo. Demo sugerida (4 min): en el Editor, pausar y avanzar frame a frame (Step) mientras dos láseres llegan a un asteroide, para mostrar que ambos OnCollisionEnter ocurren antes de que Destroy se haga efectivo al final del frame.</a:t>
+              <a:t>QUÉ SE TOCA: dónde buscar bordes cuando lo que se prueba es una interacción.</a:t>
+            </a:r>
+          </a:p>
+          <a:p>
+            <a:r>
+              <a:t>TEORÍA — en integración, el límite no es solo un número:</a:t>
+            </a:r>
+          </a:p>
+          <a:p>
+            <a:r>
+              <a:t>- Valor / posición: el umbral de un dato (y &lt; −5).</a:t>
+            </a:r>
+          </a:p>
+          <a:p>
+            <a:r>
+              <a:t>- Tiempo: intervalos y cooldowns (0,4 s).</a:t>
+            </a:r>
+          </a:p>
+          <a:p>
+            <a:r>
+              <a:t>- Cantidad / simultaneidad: 0, 1 o 2 eventos en el mismo instante.</a:t>
+            </a:r>
+          </a:p>
+          <a:p>
+            <a:r>
+              <a:t>- Repetición: llamar dos veces algo pensado para una.</a:t>
+            </a:r>
+          </a:p>
+          <a:p>
+            <a:r>
+              <a:t>- Orden: eventos que llegan en una secuencia inesperada.</a:t>
+            </a:r>
+          </a:p>
+          <a:p>
+            <a:r>
+              <a:t>ACLARACIONES: la simultaneidad es clave en Unity porque Destroy() no destruye en el acto: marca el objeto y lo elimina después del ciclo de actualización. Todas las colisiones del mismo paso de física se procesan antes, por eso dos láseres pueden «ver» vivo al mismo asteroide.</a:t>
+            </a:r>
+          </a:p>
+          <a:p>
+            <a:r>
+              <a:t>Algunos bordes no tienen respuesta en el código: la decide el diseño (¿un láser que toca dos asteroides suma 1 o 2?). Quien prueba no la inventa: la registra como pregunta.</a:t>
+            </a:r>
+          </a:p>
+          <a:p>
+            <a:r>
+              <a:t>DEMO SUGERIDA: en el Editor, pausar y avanzar frame a frame (botón Step) mientras dos láseres llegan a un asteroide.</a:t>
             </a:r>
           </a:p>
         </p:txBody>
@@ -2278,7 +3073,37 @@
           <a:lstStyle/>
           <a:p>
             <a:r>
-              <a:t>Este es el formato de ficha que usarán en las actividades (8 campos). En el juego real los asteroides aparecen en x aleatoria entre −8 y 8 (Spawner.cs 101–107), así que el choque entre asteroides es posible. Verificado en los prefabs (rama activity-r-player-health): Asteroid, Asteroid2, Asteroid3 y Asteroid4 tienen Rigidbody dinámico sin gravedad y BoxCollider que no es trigger, así que el choque entre asteroides genera OnCollisionEnter.</a:t>
+              <a:t>QUÉ SE TOCA: la ficha de 8 campos que se usa en todas las actividades.</a:t>
+            </a:r>
+          </a:p>
+          <a:p>
+            <a:r>
+              <a:t>TEORÍA: amplía la ficha de caso de prueba de la Unidad II (identificador, precondiciones, pasos, datos, resultado esperado) con tres campos propios de integración:</a:t>
+            </a:r>
+          </a:p>
+          <a:p>
+            <a:r>
+              <a:t>- Componentes: qué piezas reales participan.</a:t>
+            </a:r>
+          </a:p>
+          <a:p>
+            <a:r>
+              <a:t>- Bug que detecta: para qué existe el caso. Si no se puede completar, probablemente el caso no aporta.</a:t>
+            </a:r>
+          </a:p>
+          <a:p>
+            <a:r>
+              <a:t>- ¿Por qué integración?: qué costura (conexión entre componentes) prueba.</a:t>
+            </a:r>
+          </a:p>
+          <a:p>
+            <a:r>
+              <a:t>ACLARACIONES: el ejemplo es un caso negativo. Los asteroides aparecen en una x aleatoria entre −8 y 8 (Spawner.cs 101–107), así que el choque entre asteroides es posible en el juego real.</a:t>
+            </a:r>
+          </a:p>
+          <a:p>
+            <a:r>
+              <a:t>DATO VERIFICADO: en los prefabs, los cuatro asteroides tienen Rigidbody dinámico sin gravedad y BoxCollider que no es trigger, así que el choque genera OnCollisionEnter. Sin Rigidbody en al menos uno de los dos objetos no habría evento de colisión y el caso no probaría nada.</a:t>
             </a:r>
           </a:p>
         </p:txBody>
@@ -2348,7 +3173,27 @@
           <a:lstStyle/>
           <a:p>
             <a:r>
-              <a:t>Objetivo: diseñar casos positivos y negativos sin duplicar la suite. Resultado esperado: 6 fichas completas. Discusión: ¿un caso negativo necesita datos de prueba especiales? ¿qué positivo nuevo aporta más que otro assert en un test existente? Resolución en la diapositiva siguiente.</a:t>
+              <a:t>OBJETIVO: diseñar casos positivos y negativos sin duplicar la suite actual.</a:t>
+            </a:r>
+          </a:p>
+          <a:p>
+            <a:r>
+              <a:t>CÓMO GUIAR: para encontrar negativos, preguntar «¿qué NO debería pasar en este flujo?». Para encontrar positivos nuevos, preguntar «¿qué efecto de este flujo no verifica nadie hoy?».</a:t>
+            </a:r>
+          </a:p>
+          <a:p>
+            <a:r>
+              <a:t>RESULTADO ESPERADO: 6 fichas completas, 2 por flujo.</a:t>
+            </a:r>
+          </a:p>
+          <a:p>
+            <a:r>
+              <a:t>PREGUNTAS PARA LA DISCUSIÓN: ¿un caso negativo necesita datos de prueba especiales? ¿Un positivo nuevo aporta más que agregar otro assert a un test existente?</a:t>
+            </a:r>
+          </a:p>
+          <a:p>
+            <a:r>
+              <a:t>La resolución está en la diapositiva siguiente.</a:t>
             </a:r>
           </a:p>
         </p:txBody>

</xml_diff>